<commit_message>
studies: add pitch (plate-depth) + pin-vs-rigid studies to the OSU technical deck
Extends make_capytaine_ppt.py (11 -> 14 slides) and regenerates
Capytaine_analysis_OSU_buoy.pptx:
- "Where to put the heave plate? -- pitch performance": the plate-depth sweep
  (plate_depth_pitch_study.png) + finding (plate depth barely moves pitch; an axial
  plate meets pitch edge-on; deck tilt is a ballast/CoG job).
- "Do the buoy gimbals help? -- pin vs rigid" (setup) + "the pin wins on every axis"
  (verdict, pvr_verdict.png): same heave, rigid tilts 1.3-3.5x more, pin carries ~0
  connection moment.

Co-Authored-By: Claude Opus 4.8 <noreply@anthropic.com>
</commit_message>
<xml_diff>
--- a/studies/osu-test-buoy/Capytaine_analysis_OSU_buoy.pptx
+++ b/studies/osu-test-buoy/Capytaine_analysis_OSU_buoy.pptx
@@ -16,6 +16,9 @@
     <p:sldId id="264" r:id="rId15"/>
     <p:sldId id="265" r:id="rId16"/>
     <p:sldId id="266" r:id="rId17"/>
+    <p:sldId id="267" r:id="rId18"/>
+    <p:sldId id="268" r:id="rId19"/>
+    <p:sldId id="269" r:id="rId20"/>
   </p:sldIdLst>
   <p:sldSz cx="12191695" cy="6858000" type="screen4x3"/>
   <p:notesSz cx="6858000" cy="9144000"/>
@@ -4405,6 +4408,934 @@
 </p:sld>
 </file>
 
+<file path=ppt/slides/slide12.xml><?xml version="1.0" encoding="utf-8"?>
+<p:sld xmlns:a="http://schemas.openxmlformats.org/drawingml/2006/main" xmlns:p="http://schemas.openxmlformats.org/presentationml/2006/main" xmlns:r="http://schemas.openxmlformats.org/officeDocument/2006/relationships">
+  <p:cSld>
+    <p:bg>
+      <p:bgPr>
+        <a:solidFill>
+          <a:srgbClr val="FFFFFF"/>
+        </a:solidFill>
+        <a:effectLst/>
+      </p:bgPr>
+    </p:bg>
+    <p:spTree>
+      <p:nvGrpSpPr>
+        <p:cNvPr id="1" name=""/>
+        <p:cNvGrpSpPr/>
+        <p:nvPr/>
+      </p:nvGrpSpPr>
+      <p:grpSpPr/>
+      <p:sp>
+        <p:nvSpPr>
+          <p:cNvPr id="2" name="TextBox 1"/>
+          <p:cNvSpPr txBox="1"/>
+          <p:nvPr/>
+        </p:nvSpPr>
+        <p:spPr>
+          <a:xfrm>
+            <a:off x="640080" y="384048"/>
+            <a:ext cx="10972800" cy="365760"/>
+          </a:xfrm>
+          <a:prstGeom prst="rect">
+            <a:avLst/>
+          </a:prstGeom>
+          <a:noFill/>
+        </p:spPr>
+        <p:txBody>
+          <a:bodyPr wrap="none">
+            <a:spAutoFit/>
+          </a:bodyPr>
+          <a:lstStyle/>
+          <a:p>
+            <a:r>
+              <a:rPr sz="1300" b="1">
+                <a:solidFill>
+                  <a:srgbClr val="0C8B96"/>
+                </a:solidFill>
+                <a:latin typeface="Segoe UI"/>
+              </a:rPr>
+              <a:t>DESIGN STUDY</a:t>
+            </a:r>
+          </a:p>
+        </p:txBody>
+      </p:sp>
+      <p:sp>
+        <p:nvSpPr>
+          <p:cNvPr id="3" name="TextBox 2"/>
+          <p:cNvSpPr txBox="1"/>
+          <p:nvPr/>
+        </p:nvSpPr>
+        <p:spPr>
+          <a:xfrm>
+            <a:off x="640080" y="658368"/>
+            <a:ext cx="10972800" cy="822960"/>
+          </a:xfrm>
+          <a:prstGeom prst="rect">
+            <a:avLst/>
+          </a:prstGeom>
+          <a:noFill/>
+        </p:spPr>
+        <p:txBody>
+          <a:bodyPr wrap="none">
+            <a:spAutoFit/>
+          </a:bodyPr>
+          <a:lstStyle/>
+          <a:p>
+            <a:r>
+              <a:rPr sz="3000" b="1">
+                <a:solidFill>
+                  <a:srgbClr val="25323A"/>
+                </a:solidFill>
+                <a:latin typeface="Segoe UI"/>
+              </a:rPr>
+              <a:t>Where to put the heave plate? — pitch performance</a:t>
+            </a:r>
+          </a:p>
+        </p:txBody>
+      </p:sp>
+      <p:sp>
+        <p:nvSpPr>
+          <p:cNvPr id="4" name="Rectangle 3"/>
+          <p:cNvSpPr/>
+          <p:nvPr/>
+        </p:nvSpPr>
+        <p:spPr>
+          <a:xfrm>
+            <a:off x="658368" y="1444752"/>
+            <a:ext cx="2011680" cy="54864"/>
+          </a:xfrm>
+          <a:prstGeom prst="rect">
+            <a:avLst/>
+          </a:prstGeom>
+          <a:solidFill>
+            <a:srgbClr val="0C8B96"/>
+          </a:solidFill>
+          <a:ln>
+            <a:noFill/>
+          </a:ln>
+          <a:effectLst/>
+        </p:spPr>
+        <p:style>
+          <a:lnRef idx="1">
+            <a:schemeClr val="accent1"/>
+          </a:lnRef>
+          <a:fillRef idx="3">
+            <a:schemeClr val="accent1"/>
+          </a:fillRef>
+          <a:effectRef idx="2">
+            <a:schemeClr val="accent1"/>
+          </a:effectRef>
+          <a:fontRef idx="minor">
+            <a:schemeClr val="lt1"/>
+          </a:fontRef>
+        </p:style>
+        <p:txBody>
+          <a:bodyPr rtlCol="0" anchor="ctr"/>
+          <a:lstStyle/>
+          <a:p>
+            <a:pPr algn="ctr"/>
+          </a:p>
+        </p:txBody>
+      </p:sp>
+      <p:pic>
+        <p:nvPicPr>
+          <p:cNvPr id="5" name="Picture 4" descr="plate_depth_pitch_study.png"/>
+          <p:cNvPicPr>
+            <a:picLocks noChangeAspect="1"/>
+          </p:cNvPicPr>
+          <p:nvPr/>
+        </p:nvPicPr>
+        <p:blipFill>
+          <a:blip r:embed="rId2"/>
+          <a:stretch>
+            <a:fillRect/>
+          </a:stretch>
+        </p:blipFill>
+        <p:spPr>
+          <a:xfrm>
+            <a:off x="1298448" y="1554480"/>
+            <a:ext cx="9601200" cy="3857359"/>
+          </a:xfrm>
+          <a:prstGeom prst="rect">
+            <a:avLst/>
+          </a:prstGeom>
+        </p:spPr>
+      </p:pic>
+      <p:sp>
+        <p:nvSpPr>
+          <p:cNvPr id="6" name="Rectangle 5"/>
+          <p:cNvSpPr/>
+          <p:nvPr/>
+        </p:nvSpPr>
+        <p:spPr>
+          <a:xfrm>
+            <a:off x="777240" y="5943600"/>
+            <a:ext cx="10607040" cy="731520"/>
+          </a:xfrm>
+          <a:prstGeom prst="rect">
+            <a:avLst/>
+          </a:prstGeom>
+          <a:solidFill>
+            <a:srgbClr val="EEF6F7"/>
+          </a:solidFill>
+          <a:ln>
+            <a:noFill/>
+          </a:ln>
+          <a:effectLst/>
+        </p:spPr>
+        <p:style>
+          <a:lnRef idx="1">
+            <a:schemeClr val="accent1"/>
+          </a:lnRef>
+          <a:fillRef idx="3">
+            <a:schemeClr val="accent1"/>
+          </a:fillRef>
+          <a:effectRef idx="2">
+            <a:schemeClr val="accent1"/>
+          </a:effectRef>
+          <a:fontRef idx="minor">
+            <a:schemeClr val="lt1"/>
+          </a:fontRef>
+        </p:style>
+        <p:txBody>
+          <a:bodyPr rtlCol="0" anchor="ctr"/>
+          <a:lstStyle/>
+          <a:p>
+            <a:pPr algn="ctr"/>
+          </a:p>
+        </p:txBody>
+      </p:sp>
+      <p:sp>
+        <p:nvSpPr>
+          <p:cNvPr id="7" name="TextBox 6"/>
+          <p:cNvSpPr txBox="1"/>
+          <p:nvPr/>
+        </p:nvSpPr>
+        <p:spPr>
+          <a:xfrm>
+            <a:off x="960120" y="5980176"/>
+            <a:ext cx="10241280" cy="658368"/>
+          </a:xfrm>
+          <a:prstGeom prst="rect">
+            <a:avLst/>
+          </a:prstGeom>
+          <a:noFill/>
+        </p:spPr>
+        <p:txBody>
+          <a:bodyPr wrap="square" anchor="ctr">
+            <a:spAutoFit/>
+          </a:bodyPr>
+          <a:lstStyle/>
+          <a:p>
+            <a:pPr algn="ctr"/>
+            <a:r>
+              <a:rPr sz="1300" b="1">
+                <a:solidFill>
+                  <a:srgbClr val="0A5560"/>
+                </a:solidFill>
+                <a:latin typeface="Segoe UI"/>
+              </a:rPr>
+              <a:t>Plate depth barely moves pitch</a:t>
+            </a:r>
+            <a:r>
+              <a:rPr sz="1300" b="0">
+                <a:solidFill>
+                  <a:srgbClr val="25323A"/>
+                </a:solidFill>
+                <a:latin typeface="Segoe UI"/>
+              </a:rPr>
+              <a:t> (2.10 → 2.14 s over a 4× lever-arm change) or heave — an axial plate meets pitch EDGE-ON, so its broadside added mass &amp; drag (which dominate heave) hardly engage it.  </a:t>
+            </a:r>
+            <a:r>
+              <a:rPr sz="1300" b="1">
+                <a:solidFill>
+                  <a:srgbClr val="0A5560"/>
+                </a:solidFill>
+                <a:latin typeface="Segoe UI"/>
+              </a:rPr>
+              <a:t>Deck tilt is a ballast/CoG job, not a plate-depth job.</a:t>
+            </a:r>
+          </a:p>
+        </p:txBody>
+      </p:sp>
+    </p:spTree>
+  </p:cSld>
+  <p:clrMapOvr>
+    <a:masterClrMapping/>
+  </p:clrMapOvr>
+</p:sld>
+</file>
+
+<file path=ppt/slides/slide13.xml><?xml version="1.0" encoding="utf-8"?>
+<p:sld xmlns:a="http://schemas.openxmlformats.org/drawingml/2006/main" xmlns:p="http://schemas.openxmlformats.org/presentationml/2006/main" xmlns:r="http://schemas.openxmlformats.org/officeDocument/2006/relationships">
+  <p:cSld>
+    <p:bg>
+      <p:bgPr>
+        <a:solidFill>
+          <a:srgbClr val="FFFFFF"/>
+        </a:solidFill>
+        <a:effectLst/>
+      </p:bgPr>
+    </p:bg>
+    <p:spTree>
+      <p:nvGrpSpPr>
+        <p:cNvPr id="1" name=""/>
+        <p:cNvGrpSpPr/>
+        <p:nvPr/>
+      </p:nvGrpSpPr>
+      <p:grpSpPr/>
+      <p:sp>
+        <p:nvSpPr>
+          <p:cNvPr id="2" name="TextBox 1"/>
+          <p:cNvSpPr txBox="1"/>
+          <p:nvPr/>
+        </p:nvSpPr>
+        <p:spPr>
+          <a:xfrm>
+            <a:off x="640080" y="384048"/>
+            <a:ext cx="10972800" cy="365760"/>
+          </a:xfrm>
+          <a:prstGeom prst="rect">
+            <a:avLst/>
+          </a:prstGeom>
+          <a:noFill/>
+        </p:spPr>
+        <p:txBody>
+          <a:bodyPr wrap="none">
+            <a:spAutoFit/>
+          </a:bodyPr>
+          <a:lstStyle/>
+          <a:p>
+            <a:r>
+              <a:rPr sz="1300" b="1">
+                <a:solidFill>
+                  <a:srgbClr val="0C8B96"/>
+                </a:solidFill>
+                <a:latin typeface="Segoe UI"/>
+              </a:rPr>
+              <a:t>PLATFORM STUDY</a:t>
+            </a:r>
+          </a:p>
+        </p:txBody>
+      </p:sp>
+      <p:sp>
+        <p:nvSpPr>
+          <p:cNvPr id="3" name="TextBox 2"/>
+          <p:cNvSpPr txBox="1"/>
+          <p:nvPr/>
+        </p:nvSpPr>
+        <p:spPr>
+          <a:xfrm>
+            <a:off x="640080" y="658368"/>
+            <a:ext cx="10972800" cy="822960"/>
+          </a:xfrm>
+          <a:prstGeom prst="rect">
+            <a:avLst/>
+          </a:prstGeom>
+          <a:noFill/>
+        </p:spPr>
+        <p:txBody>
+          <a:bodyPr wrap="none">
+            <a:spAutoFit/>
+          </a:bodyPr>
+          <a:lstStyle/>
+          <a:p>
+            <a:r>
+              <a:rPr sz="3000" b="1">
+                <a:solidFill>
+                  <a:srgbClr val="25323A"/>
+                </a:solidFill>
+                <a:latin typeface="Segoe UI"/>
+              </a:rPr>
+              <a:t>Do the buoy gimbals help the platform? — pin vs rigid</a:t>
+            </a:r>
+          </a:p>
+        </p:txBody>
+      </p:sp>
+      <p:sp>
+        <p:nvSpPr>
+          <p:cNvPr id="4" name="Rectangle 3"/>
+          <p:cNvSpPr/>
+          <p:nvPr/>
+        </p:nvSpPr>
+        <p:spPr>
+          <a:xfrm>
+            <a:off x="658368" y="1444752"/>
+            <a:ext cx="2011680" cy="54864"/>
+          </a:xfrm>
+          <a:prstGeom prst="rect">
+            <a:avLst/>
+          </a:prstGeom>
+          <a:solidFill>
+            <a:srgbClr val="0C8B96"/>
+          </a:solidFill>
+          <a:ln>
+            <a:noFill/>
+          </a:ln>
+          <a:effectLst/>
+        </p:spPr>
+        <p:style>
+          <a:lnRef idx="1">
+            <a:schemeClr val="accent1"/>
+          </a:lnRef>
+          <a:fillRef idx="3">
+            <a:schemeClr val="accent1"/>
+          </a:fillRef>
+          <a:effectRef idx="2">
+            <a:schemeClr val="accent1"/>
+          </a:effectRef>
+          <a:fontRef idx="minor">
+            <a:schemeClr val="lt1"/>
+          </a:fontRef>
+        </p:style>
+        <p:txBody>
+          <a:bodyPr rtlCol="0" anchor="ctr"/>
+          <a:lstStyle/>
+          <a:p>
+            <a:pPr algn="ctr"/>
+          </a:p>
+        </p:txBody>
+      </p:sp>
+      <p:sp>
+        <p:nvSpPr>
+          <p:cNvPr id="5" name="TextBox 4"/>
+          <p:cNvSpPr txBox="1"/>
+          <p:nvPr/>
+        </p:nvSpPr>
+        <p:spPr>
+          <a:xfrm>
+            <a:off x="777240" y="1920240"/>
+            <a:ext cx="10698480" cy="4572000"/>
+          </a:xfrm>
+          <a:prstGeom prst="rect">
+            <a:avLst/>
+          </a:prstGeom>
+          <a:noFill/>
+        </p:spPr>
+        <p:txBody>
+          <a:bodyPr wrap="square">
+            <a:spAutoFit/>
+          </a:bodyPr>
+          <a:lstStyle/>
+          <a:p>
+            <a:pPr>
+              <a:spcBef>
+                <a:spcPts val="200"/>
+              </a:spcBef>
+              <a:spcAft>
+                <a:spcPts val="1200"/>
+              </a:spcAft>
+            </a:pPr>
+            <a:r>
+              <a:rPr sz="1800">
+                <a:solidFill>
+                  <a:srgbClr val="0C8B96"/>
+                </a:solidFill>
+                <a:latin typeface="Segoe UI"/>
+              </a:rPr>
+              <a:t>•  </a:t>
+            </a:r>
+            <a:r>
+              <a:rPr sz="1800" b="0" i="0">
+                <a:solidFill>
+                  <a:srgbClr val="25323A"/>
+                </a:solidFill>
+                <a:latin typeface="Segoe UI"/>
+              </a:rPr>
+              <a:t>Scaling up: 16 buoys on a shared platform — a </a:t>
+            </a:r>
+            <a:r>
+              <a:rPr sz="1800" b="1" i="0">
+                <a:solidFill>
+                  <a:srgbClr val="25323A"/>
+                </a:solidFill>
+                <a:latin typeface="Segoe UI"/>
+              </a:rPr>
+              <a:t>still, level deck</a:t>
+            </a:r>
+            <a:r>
+              <a:rPr sz="1800" b="0" i="0">
+                <a:solidFill>
+                  <a:srgbClr val="25323A"/>
+                </a:solidFill>
+                <a:latin typeface="Segoe UI"/>
+              </a:rPr>
+              <a:t> for rockets / datacenters / hotels.</a:t>
+            </a:r>
+          </a:p>
+          <a:p>
+            <a:pPr>
+              <a:spcBef>
+                <a:spcPts val="200"/>
+              </a:spcBef>
+              <a:spcAft>
+                <a:spcPts val="1200"/>
+              </a:spcAft>
+            </a:pPr>
+            <a:r>
+              <a:rPr sz="1800">
+                <a:solidFill>
+                  <a:srgbClr val="0C8B96"/>
+                </a:solidFill>
+                <a:latin typeface="Segoe UI"/>
+              </a:rPr>
+              <a:t>•  </a:t>
+            </a:r>
+            <a:r>
+              <a:rPr sz="1800" b="0" i="0">
+                <a:solidFill>
+                  <a:srgbClr val="25323A"/>
+                </a:solidFill>
+                <a:latin typeface="Segoe UI"/>
+              </a:rPr>
+              <a:t>Each buoy joins the platform through the </a:t>
+            </a:r>
+            <a:r>
+              <a:rPr sz="1800" b="1" i="0">
+                <a:solidFill>
+                  <a:srgbClr val="25323A"/>
+                </a:solidFill>
+                <a:latin typeface="Segoe UI"/>
+              </a:rPr>
+              <a:t>gimbal at its top</a:t>
+            </a:r>
+            <a:r>
+              <a:rPr sz="1800" b="0" i="0">
+                <a:solidFill>
+                  <a:srgbClr val="25323A"/>
+                </a:solidFill>
+                <a:latin typeface="Segoe UI"/>
+              </a:rPr>
+              <a:t> (a pin: roll/pitch free). Does that beat welding the assembly rigid?</a:t>
+            </a:r>
+          </a:p>
+          <a:p>
+            <a:pPr>
+              <a:spcBef>
+                <a:spcPts val="200"/>
+              </a:spcBef>
+              <a:spcAft>
+                <a:spcPts val="1200"/>
+              </a:spcAft>
+            </a:pPr>
+            <a:r>
+              <a:rPr sz="1800">
+                <a:solidFill>
+                  <a:srgbClr val="0C8B96"/>
+                </a:solidFill>
+                <a:latin typeface="Segoe UI"/>
+              </a:rPr>
+              <a:t>•  </a:t>
+            </a:r>
+            <a:r>
+              <a:rPr sz="1800" b="0" i="0">
+                <a:solidFill>
+                  <a:srgbClr val="25323A"/>
+                </a:solidFill>
+                <a:latin typeface="Segoe UI"/>
+              </a:rPr>
+              <a:t>Same 16-buoy deck, same hydro / drag / geometry — only the joint type changes:</a:t>
+            </a:r>
+          </a:p>
+          <a:p>
+            <a:pPr lvl="1">
+              <a:spcBef>
+                <a:spcPts val="200"/>
+              </a:spcBef>
+              <a:spcAft>
+                <a:spcPts val="1200"/>
+              </a:spcAft>
+            </a:pPr>
+            <a:r>
+              <a:rPr sz="1800">
+                <a:solidFill>
+                  <a:srgbClr val="54636D"/>
+                </a:solidFill>
+                <a:latin typeface="Segoe UI"/>
+              </a:rPr>
+              <a:t>      –  </a:t>
+            </a:r>
+            <a:r>
+              <a:rPr sz="1600" b="1" i="0">
+                <a:solidFill>
+                  <a:srgbClr val="0A5560"/>
+                </a:solidFill>
+                <a:latin typeface="Segoe UI"/>
+              </a:rPr>
+              <a:t>Articulated</a:t>
+            </a:r>
+            <a:r>
+              <a:rPr sz="1600" b="0" i="0">
+                <a:solidFill>
+                  <a:srgbClr val="25323A"/>
+                </a:solidFill>
+                <a:latin typeface="Segoe UI"/>
+              </a:rPr>
+              <a:t> — every joint a pin (the current design)</a:t>
+            </a:r>
+          </a:p>
+          <a:p>
+            <a:pPr lvl="1">
+              <a:spcBef>
+                <a:spcPts val="200"/>
+              </a:spcBef>
+              <a:spcAft>
+                <a:spcPts val="1200"/>
+              </a:spcAft>
+            </a:pPr>
+            <a:r>
+              <a:rPr sz="1800">
+                <a:solidFill>
+                  <a:srgbClr val="54636D"/>
+                </a:solidFill>
+                <a:latin typeface="Segoe UI"/>
+              </a:rPr>
+              <a:t>      –  </a:t>
+            </a:r>
+            <a:r>
+              <a:rPr sz="1600" b="1" i="0">
+                <a:solidFill>
+                  <a:srgbClr val="D1543A"/>
+                </a:solidFill>
+                <a:latin typeface="Segoe UI"/>
+              </a:rPr>
+              <a:t>Whole-chain rigid</a:t>
+            </a:r>
+            <a:r>
+              <a:rPr sz="1600" b="0" i="0">
+                <a:solidFill>
+                  <a:srgbClr val="25323A"/>
+                </a:solidFill>
+                <a:latin typeface="Segoe UI"/>
+              </a:rPr>
+              <a:t> — every joint welded → one rigid raft</a:t>
+            </a:r>
+          </a:p>
+          <a:p>
+            <a:pPr>
+              <a:spcBef>
+                <a:spcPts val="200"/>
+              </a:spcBef>
+              <a:spcAft>
+                <a:spcPts val="1200"/>
+              </a:spcAft>
+            </a:pPr>
+            <a:r>
+              <a:rPr sz="1800">
+                <a:solidFill>
+                  <a:srgbClr val="0C8B96"/>
+                </a:solidFill>
+                <a:latin typeface="Segoe UI"/>
+              </a:rPr>
+              <a:t>•  </a:t>
+            </a:r>
+            <a:r>
+              <a:rPr sz="1800" b="0" i="0">
+                <a:solidFill>
+                  <a:srgbClr val="25323A"/>
+                </a:solidFill>
+                <a:latin typeface="Segoe UI"/>
+              </a:rPr>
+              <a:t>Metrics: deck tilt (pitch), heave, and the moment carried at each buoy→platform joint.</a:t>
+            </a:r>
+          </a:p>
+        </p:txBody>
+      </p:sp>
+    </p:spTree>
+  </p:cSld>
+  <p:clrMapOvr>
+    <a:masterClrMapping/>
+  </p:clrMapOvr>
+</p:sld>
+</file>
+
+<file path=ppt/slides/slide14.xml><?xml version="1.0" encoding="utf-8"?>
+<p:sld xmlns:a="http://schemas.openxmlformats.org/drawingml/2006/main" xmlns:p="http://schemas.openxmlformats.org/presentationml/2006/main" xmlns:r="http://schemas.openxmlformats.org/officeDocument/2006/relationships">
+  <p:cSld>
+    <p:bg>
+      <p:bgPr>
+        <a:solidFill>
+          <a:srgbClr val="FFFFFF"/>
+        </a:solidFill>
+        <a:effectLst/>
+      </p:bgPr>
+    </p:bg>
+    <p:spTree>
+      <p:nvGrpSpPr>
+        <p:cNvPr id="1" name=""/>
+        <p:cNvGrpSpPr/>
+        <p:nvPr/>
+      </p:nvGrpSpPr>
+      <p:grpSpPr/>
+      <p:sp>
+        <p:nvSpPr>
+          <p:cNvPr id="2" name="TextBox 1"/>
+          <p:cNvSpPr txBox="1"/>
+          <p:nvPr/>
+        </p:nvSpPr>
+        <p:spPr>
+          <a:xfrm>
+            <a:off x="640080" y="384048"/>
+            <a:ext cx="10972800" cy="365760"/>
+          </a:xfrm>
+          <a:prstGeom prst="rect">
+            <a:avLst/>
+          </a:prstGeom>
+          <a:noFill/>
+        </p:spPr>
+        <p:txBody>
+          <a:bodyPr wrap="none">
+            <a:spAutoFit/>
+          </a:bodyPr>
+          <a:lstStyle/>
+          <a:p>
+            <a:r>
+              <a:rPr sz="1300" b="1">
+                <a:solidFill>
+                  <a:srgbClr val="0C8B96"/>
+                </a:solidFill>
+                <a:latin typeface="Segoe UI"/>
+              </a:rPr>
+              <a:t>PLATFORM STUDY</a:t>
+            </a:r>
+          </a:p>
+        </p:txBody>
+      </p:sp>
+      <p:sp>
+        <p:nvSpPr>
+          <p:cNvPr id="3" name="TextBox 2"/>
+          <p:cNvSpPr txBox="1"/>
+          <p:nvPr/>
+        </p:nvSpPr>
+        <p:spPr>
+          <a:xfrm>
+            <a:off x="640080" y="658368"/>
+            <a:ext cx="10972800" cy="822960"/>
+          </a:xfrm>
+          <a:prstGeom prst="rect">
+            <a:avLst/>
+          </a:prstGeom>
+          <a:noFill/>
+        </p:spPr>
+        <p:txBody>
+          <a:bodyPr wrap="none">
+            <a:spAutoFit/>
+          </a:bodyPr>
+          <a:lstStyle/>
+          <a:p>
+            <a:r>
+              <a:rPr sz="3000" b="1">
+                <a:solidFill>
+                  <a:srgbClr val="25323A"/>
+                </a:solidFill>
+                <a:latin typeface="Segoe UI"/>
+              </a:rPr>
+              <a:t>Pin vs rigid — the pin wins on every axis</a:t>
+            </a:r>
+          </a:p>
+        </p:txBody>
+      </p:sp>
+      <p:sp>
+        <p:nvSpPr>
+          <p:cNvPr id="4" name="Rectangle 3"/>
+          <p:cNvSpPr/>
+          <p:nvPr/>
+        </p:nvSpPr>
+        <p:spPr>
+          <a:xfrm>
+            <a:off x="658368" y="1444752"/>
+            <a:ext cx="2011680" cy="54864"/>
+          </a:xfrm>
+          <a:prstGeom prst="rect">
+            <a:avLst/>
+          </a:prstGeom>
+          <a:solidFill>
+            <a:srgbClr val="0C8B96"/>
+          </a:solidFill>
+          <a:ln>
+            <a:noFill/>
+          </a:ln>
+          <a:effectLst/>
+        </p:spPr>
+        <p:style>
+          <a:lnRef idx="1">
+            <a:schemeClr val="accent1"/>
+          </a:lnRef>
+          <a:fillRef idx="3">
+            <a:schemeClr val="accent1"/>
+          </a:fillRef>
+          <a:effectRef idx="2">
+            <a:schemeClr val="accent1"/>
+          </a:effectRef>
+          <a:fontRef idx="minor">
+            <a:schemeClr val="lt1"/>
+          </a:fontRef>
+        </p:style>
+        <p:txBody>
+          <a:bodyPr rtlCol="0" anchor="ctr"/>
+          <a:lstStyle/>
+          <a:p>
+            <a:pPr algn="ctr"/>
+          </a:p>
+        </p:txBody>
+      </p:sp>
+      <p:pic>
+        <p:nvPicPr>
+          <p:cNvPr id="5" name="Picture 4" descr="pvr_verdict.png"/>
+          <p:cNvPicPr>
+            <a:picLocks noChangeAspect="1"/>
+          </p:cNvPicPr>
+          <p:nvPr/>
+        </p:nvPicPr>
+        <p:blipFill>
+          <a:blip r:embed="rId2"/>
+          <a:stretch>
+            <a:fillRect/>
+          </a:stretch>
+        </p:blipFill>
+        <p:spPr>
+          <a:xfrm>
+            <a:off x="640080" y="1783080"/>
+            <a:ext cx="10972800" cy="3614624"/>
+          </a:xfrm>
+          <a:prstGeom prst="rect">
+            <a:avLst/>
+          </a:prstGeom>
+        </p:spPr>
+      </p:pic>
+      <p:sp>
+        <p:nvSpPr>
+          <p:cNvPr id="6" name="Rectangle 5"/>
+          <p:cNvSpPr/>
+          <p:nvPr/>
+        </p:nvSpPr>
+        <p:spPr>
+          <a:xfrm>
+            <a:off x="777240" y="5806440"/>
+            <a:ext cx="10607040" cy="749808"/>
+          </a:xfrm>
+          <a:prstGeom prst="rect">
+            <a:avLst/>
+          </a:prstGeom>
+          <a:solidFill>
+            <a:srgbClr val="EEF6F7"/>
+          </a:solidFill>
+          <a:ln>
+            <a:noFill/>
+          </a:ln>
+          <a:effectLst/>
+        </p:spPr>
+        <p:style>
+          <a:lnRef idx="1">
+            <a:schemeClr val="accent1"/>
+          </a:lnRef>
+          <a:fillRef idx="3">
+            <a:schemeClr val="accent1"/>
+          </a:fillRef>
+          <a:effectRef idx="2">
+            <a:schemeClr val="accent1"/>
+          </a:effectRef>
+          <a:fontRef idx="minor">
+            <a:schemeClr val="lt1"/>
+          </a:fontRef>
+        </p:style>
+        <p:txBody>
+          <a:bodyPr rtlCol="0" anchor="ctr"/>
+          <a:lstStyle/>
+          <a:p>
+            <a:pPr algn="ctr"/>
+          </a:p>
+        </p:txBody>
+      </p:sp>
+      <p:sp>
+        <p:nvSpPr>
+          <p:cNvPr id="7" name="TextBox 6"/>
+          <p:cNvSpPr txBox="1"/>
+          <p:nvPr/>
+        </p:nvSpPr>
+        <p:spPr>
+          <a:xfrm>
+            <a:off x="960120" y="5852160"/>
+            <a:ext cx="10241280" cy="658368"/>
+          </a:xfrm>
+          <a:prstGeom prst="rect">
+            <a:avLst/>
+          </a:prstGeom>
+          <a:noFill/>
+        </p:spPr>
+        <p:txBody>
+          <a:bodyPr wrap="square" anchor="ctr">
+            <a:spAutoFit/>
+          </a:bodyPr>
+          <a:lstStyle/>
+          <a:p>
+            <a:pPr algn="ctr"/>
+            <a:r>
+              <a:rPr sz="1300" b="1">
+                <a:solidFill>
+                  <a:srgbClr val="0A5560"/>
+                </a:solidFill>
+                <a:latin typeface="Segoe UI"/>
+              </a:rPr>
+              <a:t>Same heave</a:t>
+            </a:r>
+            <a:r>
+              <a:rPr sz="1300" b="0">
+                <a:solidFill>
+                  <a:srgbClr val="25323A"/>
+                </a:solidFill>
+                <a:latin typeface="Segoe UI"/>
+              </a:rPr>
+              <a:t>; the rigid raft tilts </a:t>
+            </a:r>
+            <a:r>
+              <a:rPr sz="1300" b="1">
+                <a:solidFill>
+                  <a:srgbClr val="D1543A"/>
+                </a:solidFill>
+                <a:latin typeface="Segoe UI"/>
+              </a:rPr>
+              <a:t>1.3–3.5× more</a:t>
+            </a:r>
+            <a:r>
+              <a:rPr sz="1300" b="0">
+                <a:solidFill>
+                  <a:srgbClr val="25323A"/>
+                </a:solidFill>
+                <a:latin typeface="Segoe UI"/>
+              </a:rPr>
+              <a:t>; and the pin carries </a:t>
+            </a:r>
+            <a:r>
+              <a:rPr sz="1300" b="1">
+                <a:solidFill>
+                  <a:srgbClr val="0A5560"/>
+                </a:solidFill>
+                <a:latin typeface="Segoe UI"/>
+              </a:rPr>
+              <a:t>~zero connection moment</a:t>
+            </a:r>
+            <a:r>
+              <a:rPr sz="1300" b="0">
+                <a:solidFill>
+                  <a:srgbClr val="25323A"/>
+                </a:solidFill>
+                <a:latin typeface="Segoe UI"/>
+              </a:rPr>
+              <a:t> vs the weld's hundreds of N·m/m. The gimbals absorb buoy tilt instead of dumping it into the deck.</a:t>
+            </a:r>
+          </a:p>
+        </p:txBody>
+      </p:sp>
+    </p:spTree>
+  </p:cSld>
+  <p:clrMapOvr>
+    <a:masterClrMapping/>
+  </p:clrMapOvr>
+</p:sld>
+</file>
+
 <file path=ppt/slides/slide2.xml><?xml version="1.0" encoding="utf-8"?>
 <p:sld xmlns:a="http://schemas.openxmlformats.org/drawingml/2006/main" xmlns:p="http://schemas.openxmlformats.org/presentationml/2006/main" xmlns:r="http://schemas.openxmlformats.org/officeDocument/2006/relationships">
   <p:cSld>

</xml_diff>